<commit_message>
Scheduled snapshot t16 (2026-07-27): fresh IG/FB/YT/TT + rebuilt decks
Co-Authored-By: Claude Opus 4.7 (1M context) <noreply@anthropic.com>
</commit_message>
<xml_diff>
--- a/MONTHLY_REPORT_2026-07.pptx
+++ b/MONTHLY_REPORT_2026-07.pptx
@@ -3613,7 +3613,7 @@
                 </a:solidFill>
                 <a:latin typeface="Georgia"/>
               </a:rPr>
-              <a:t>127</a:t>
+              <a:t>133</a:t>
             </a:r>
           </a:p>
         </p:txBody>
@@ -3839,7 +3839,7 @@
                 </a:solidFill>
                 <a:latin typeface="Georgia"/>
               </a:rPr>
-              <a:t>2,698 → 0</a:t>
+              <a:t>2,699 → 0</a:t>
             </a:r>
           </a:p>
         </p:txBody>
@@ -4063,7 +4063,7 @@
                 </a:solidFill>
                 <a:latin typeface="Georgia"/>
               </a:rPr>
-              <a:t>1,121 → 318</a:t>
+              <a:t>1,121 → 324</a:t>
             </a:r>
           </a:p>
         </p:txBody>
@@ -4097,7 +4097,7 @@
                 </a:solidFill>
                 <a:latin typeface="Helvetica Neue"/>
               </a:rPr>
-              <a:t>▼ -72%</a:t>
+              <a:t>▼ -71%</a:t>
             </a:r>
           </a:p>
         </p:txBody>
@@ -4287,7 +4287,7 @@
                 </a:solidFill>
                 <a:latin typeface="Georgia"/>
               </a:rPr>
-              <a:t>632 → 6,083</a:t>
+              <a:t>632 → 7,171</a:t>
             </a:r>
           </a:p>
         </p:txBody>
@@ -4321,7 +4321,7 @@
                 </a:solidFill>
                 <a:latin typeface="Helvetica Neue"/>
               </a:rPr>
-              <a:t>▲ +863%</a:t>
+              <a:t>▲ +1035%</a:t>
             </a:r>
           </a:p>
         </p:txBody>
@@ -4743,7 +4743,7 @@
                 </a:solidFill>
                 <a:latin typeface="Helvetica Neue"/>
               </a:rPr>
-              <a:t>July views (42 posts)</a:t>
+              <a:t>July views (44 posts)</a:t>
             </a:r>
           </a:p>
         </p:txBody>
@@ -5045,7 +5045,7 @@
                 </a:solidFill>
                 <a:latin typeface="Georgia"/>
               </a:rPr>
-              <a:t>81,485</a:t>
+              <a:t>89,107</a:t>
             </a:r>
           </a:p>
         </p:txBody>
@@ -5079,7 +5079,7 @@
                 </a:solidFill>
                 <a:latin typeface="Helvetica Neue"/>
               </a:rPr>
-              <a:t>July views (38 posts)</a:t>
+              <a:t>July views (40 posts)</a:t>
             </a:r>
           </a:p>
         </p:txBody>
@@ -5381,7 +5381,7 @@
                 </a:solidFill>
                 <a:latin typeface="Georgia"/>
               </a:rPr>
-              <a:t>32,797</a:t>
+              <a:t>35,505</a:t>
             </a:r>
           </a:p>
         </p:txBody>
@@ -5415,7 +5415,7 @@
                 </a:solidFill>
                 <a:latin typeface="Helvetica Neue"/>
               </a:rPr>
-              <a:t>July views (43 posts)</a:t>
+              <a:t>July views (45 posts)</a:t>
             </a:r>
           </a:p>
         </p:txBody>
@@ -5717,7 +5717,7 @@
                 </a:solidFill>
                 <a:latin typeface="Georgia"/>
               </a:rPr>
-              <a:t>266</a:t>
+              <a:t>297</a:t>
             </a:r>
           </a:p>
         </p:txBody>
@@ -5863,7 +5863,7 @@
                 </a:solidFill>
                 <a:latin typeface="Helvetica Neue"/>
               </a:rPr>
-              <a:t>715</a:t>
+              <a:t>723</a:t>
             </a:r>
           </a:p>
         </p:txBody>
@@ -6251,7 +6251,7 @@
                 </a:solidFill>
                 <a:latin typeface="Georgia"/>
               </a:rPr>
-              <a:t>4,603</a:t>
+              <a:t>4,605</a:t>
             </a:r>
           </a:p>
         </p:txBody>
@@ -6319,7 +6319,7 @@
                 </a:solidFill>
                 <a:latin typeface="Helvetica Neue"/>
               </a:rPr>
-              <a:t>10 posts · 46,034 total views</a:t>
+              <a:t>10 posts · 46,049 total views</a:t>
             </a:r>
           </a:p>
         </p:txBody>
@@ -6475,7 +6475,7 @@
                 </a:solidFill>
                 <a:latin typeface="Georgia"/>
               </a:rPr>
-              <a:t>6,083</a:t>
+              <a:t>7,171</a:t>
             </a:r>
           </a:p>
         </p:txBody>
@@ -6543,7 +6543,7 @@
                 </a:solidFill>
                 <a:latin typeface="Helvetica Neue"/>
               </a:rPr>
-              <a:t>5 posts · 30,416 total views</a:t>
+              <a:t>5 posts · 35,856 total views</a:t>
             </a:r>
           </a:p>
         </p:txBody>
@@ -6699,7 +6699,7 @@
                 </a:solidFill>
                 <a:latin typeface="Georgia"/>
               </a:rPr>
-              <a:t>464</a:t>
+              <a:t>476</a:t>
             </a:r>
           </a:p>
         </p:txBody>
@@ -6767,7 +6767,7 @@
                 </a:solidFill>
                 <a:latin typeface="Helvetica Neue"/>
               </a:rPr>
-              <a:t>48 posts · 22,269 total views</a:t>
+              <a:t>54 posts · 25,722 total views</a:t>
             </a:r>
           </a:p>
         </p:txBody>
@@ -6923,7 +6923,7 @@
                 </a:solidFill>
                 <a:latin typeface="Georgia"/>
               </a:rPr>
-              <a:t>727</a:t>
+              <a:t>755</a:t>
             </a:r>
           </a:p>
         </p:txBody>
@@ -6991,7 +6991,7 @@
                 </a:solidFill>
                 <a:latin typeface="Helvetica Neue"/>
               </a:rPr>
-              <a:t>15 posts · 10,899 total views</a:t>
+              <a:t>15 posts · 11,331 total views</a:t>
             </a:r>
           </a:p>
         </p:txBody>
@@ -7147,7 +7147,7 @@
                 </a:solidFill>
                 <a:latin typeface="Georgia"/>
               </a:rPr>
-              <a:t>283</a:t>
+              <a:t>297</a:t>
             </a:r>
           </a:p>
         </p:txBody>
@@ -7215,7 +7215,7 @@
                 </a:solidFill>
                 <a:latin typeface="Helvetica Neue"/>
               </a:rPr>
-              <a:t>17 posts · 4,804 total views</a:t>
+              <a:t>17 posts · 5,042 total views</a:t>
             </a:r>
           </a:p>
         </p:txBody>
@@ -7371,7 +7371,7 @@
                 </a:solidFill>
                 <a:latin typeface="Georgia"/>
               </a:rPr>
-              <a:t>1,004</a:t>
+              <a:t>1,012</a:t>
             </a:r>
           </a:p>
         </p:txBody>
@@ -7439,7 +7439,7 @@
                 </a:solidFill>
                 <a:latin typeface="Helvetica Neue"/>
               </a:rPr>
-              <a:t>4 posts · 4,018 total views</a:t>
+              <a:t>4 posts · 4,050 total views</a:t>
             </a:r>
           </a:p>
         </p:txBody>
@@ -7595,7 +7595,7 @@
                 </a:solidFill>
                 <a:latin typeface="Georgia"/>
               </a:rPr>
-              <a:t>1,002</a:t>
+              <a:t>1,006</a:t>
             </a:r>
           </a:p>
         </p:txBody>
@@ -7663,7 +7663,7 @@
                 </a:solidFill>
                 <a:latin typeface="Helvetica Neue"/>
               </a:rPr>
-              <a:t>4 posts · 4,006 total views</a:t>
+              <a:t>4 posts · 4,026 total views</a:t>
             </a:r>
           </a:p>
         </p:txBody>
@@ -7819,7 +7819,7 @@
                 </a:solidFill>
                 <a:latin typeface="Georgia"/>
               </a:rPr>
-              <a:t>465</a:t>
+              <a:t>468</a:t>
             </a:r>
           </a:p>
         </p:txBody>
@@ -7887,7 +7887,7 @@
                 </a:solidFill>
                 <a:latin typeface="Helvetica Neue"/>
               </a:rPr>
-              <a:t>8 posts · 3,722 total views</a:t>
+              <a:t>8 posts · 3,744 total views</a:t>
             </a:r>
           </a:p>
         </p:txBody>
@@ -8513,7 +8513,7 @@
                 </a:solidFill>
                 <a:latin typeface="Helvetica Neue"/>
               </a:rPr>
-              <a:t>28,000</a:t>
+              <a:t>33,400</a:t>
             </a:r>
           </a:p>
         </p:txBody>
@@ -8547,7 +8547,7 @@
                 </a:solidFill>
                 <a:latin typeface="Helvetica Neue"/>
               </a:rPr>
-              <a:t>1,700</a:t>
+              <a:t>2,122</a:t>
             </a:r>
           </a:p>
         </p:txBody>
@@ -9053,7 +9053,7 @@
                 </a:solidFill>
                 <a:latin typeface="Helvetica Neue"/>
               </a:rPr>
-              <a:t>7,360</a:t>
+              <a:t>7,698</a:t>
             </a:r>
           </a:p>
         </p:txBody>
@@ -9087,7 +9087,7 @@
                 </a:solidFill>
                 <a:latin typeface="Helvetica Neue"/>
               </a:rPr>
-              <a:t>364</a:t>
+              <a:t>377</a:t>
             </a:r>
           </a:p>
         </p:txBody>
@@ -9957,7 +9957,7 @@
                 </a:solidFill>
                 <a:latin typeface="Helvetica Neue"/>
               </a:rPr>
-              <a:t>1,641</a:t>
+              <a:t>1,788</a:t>
             </a:r>
           </a:p>
         </p:txBody>
@@ -9991,7 +9991,7 @@
                 </a:solidFill>
                 <a:latin typeface="Helvetica Neue"/>
               </a:rPr>
-              <a:t>23</a:t>
+              <a:t>28</a:t>
             </a:r>
           </a:p>
         </p:txBody>
@@ -10205,7 +10205,7 @@
                 </a:solidFill>
                 <a:latin typeface="Helvetica Neue"/>
               </a:rPr>
-              <a:t>1,584</a:t>
+              <a:t>1,705</a:t>
             </a:r>
           </a:p>
         </p:txBody>
@@ -10549,7 +10549,7 @@
                 </a:solidFill>
                 <a:latin typeface="Helvetica Neue"/>
               </a:rPr>
-              <a:t>—  June posts (Jun 8–30 window): 131  →  July posts (Jul 1–31 window): 127</a:t>
+              <a:t>—  June posts (Jun 8–30 window): 131  →  July posts (Jul 1–31 window): 133</a:t>
             </a:r>
           </a:p>
         </p:txBody>

</xml_diff>

<commit_message>
Scheduled snapshot t17 (2026-08-10): fresh IG/FB/YT/TT + rebuilt decks
Co-Authored-By: Claude Opus 4.7 (1M context) <noreply@anthropic.com>
</commit_message>
<xml_diff>
--- a/MONTHLY_REPORT_2026-07.pptx
+++ b/MONTHLY_REPORT_2026-07.pptx
@@ -3414,7 +3414,7 @@
                 </a:solidFill>
                 <a:latin typeface="Helvetica Neue"/>
               </a:rPr>
-              <a:t>Prepared by Zhamir Pascual — Kaname Z</a:t>
+              <a:t>Prepared by Zhamir Pascual — Z</a:t>
             </a:r>
           </a:p>
         </p:txBody>
@@ -3613,7 +3613,7 @@
                 </a:solidFill>
                 <a:latin typeface="Georgia"/>
               </a:rPr>
-              <a:t>133</a:t>
+              <a:t>163</a:t>
             </a:r>
           </a:p>
         </p:txBody>
@@ -3839,7 +3839,7 @@
                 </a:solidFill>
                 <a:latin typeface="Georgia"/>
               </a:rPr>
-              <a:t>2,699 → 0</a:t>
+              <a:t>2,500 → 0</a:t>
             </a:r>
           </a:p>
         </p:txBody>
@@ -4063,7 +4063,7 @@
                 </a:solidFill>
                 <a:latin typeface="Georgia"/>
               </a:rPr>
-              <a:t>1,121 → 324</a:t>
+              <a:t>1,121 → 335</a:t>
             </a:r>
           </a:p>
         </p:txBody>
@@ -4097,7 +4097,7 @@
                 </a:solidFill>
                 <a:latin typeface="Helvetica Neue"/>
               </a:rPr>
-              <a:t>▼ -71%</a:t>
+              <a:t>▼ -70%</a:t>
             </a:r>
           </a:p>
         </p:txBody>
@@ -4287,7 +4287,7 @@
                 </a:solidFill>
                 <a:latin typeface="Georgia"/>
               </a:rPr>
-              <a:t>632 → 7,171</a:t>
+              <a:t>948 → 480</a:t>
             </a:r>
           </a:p>
         </p:txBody>
@@ -4317,11 +4317,11 @@
             <a:r>
               <a:rPr sz="1800" b="1">
                 <a:solidFill>
-                  <a:srgbClr val="1B7A43"/>
-                </a:solidFill>
-                <a:latin typeface="Helvetica Neue"/>
-              </a:rPr>
-              <a:t>▲ +1035%</a:t>
+                  <a:srgbClr val="990011"/>
+                </a:solidFill>
+                <a:latin typeface="Helvetica Neue"/>
+              </a:rPr>
+              <a:t>▼ -49%</a:t>
             </a:r>
           </a:p>
         </p:txBody>
@@ -4709,7 +4709,7 @@
                 </a:solidFill>
                 <a:latin typeface="Georgia"/>
               </a:rPr>
-              <a:t>16,226</a:t>
+              <a:t>47,752</a:t>
             </a:r>
           </a:p>
         </p:txBody>
@@ -4743,7 +4743,7 @@
                 </a:solidFill>
                 <a:latin typeface="Helvetica Neue"/>
               </a:rPr>
-              <a:t>July views (44 posts)</a:t>
+              <a:t>July views (54 posts)</a:t>
             </a:r>
           </a:p>
         </p:txBody>
@@ -5045,7 +5045,7 @@
                 </a:solidFill>
                 <a:latin typeface="Georgia"/>
               </a:rPr>
-              <a:t>89,107</a:t>
+              <a:t>111,267</a:t>
             </a:r>
           </a:p>
         </p:txBody>
@@ -5079,7 +5079,7 @@
                 </a:solidFill>
                 <a:latin typeface="Helvetica Neue"/>
               </a:rPr>
-              <a:t>July views (40 posts)</a:t>
+              <a:t>July views (50 posts)</a:t>
             </a:r>
           </a:p>
         </p:txBody>
@@ -5381,7 +5381,7 @@
                 </a:solidFill>
                 <a:latin typeface="Georgia"/>
               </a:rPr>
-              <a:t>35,505</a:t>
+              <a:t>45,774</a:t>
             </a:r>
           </a:p>
         </p:txBody>
@@ -5415,7 +5415,7 @@
                 </a:solidFill>
                 <a:latin typeface="Helvetica Neue"/>
               </a:rPr>
-              <a:t>July views (45 posts)</a:t>
+              <a:t>July views (55 posts)</a:t>
             </a:r>
           </a:p>
         </p:txBody>
@@ -5717,7 +5717,7 @@
                 </a:solidFill>
                 <a:latin typeface="Georgia"/>
               </a:rPr>
-              <a:t>297</a:t>
+              <a:t>359</a:t>
             </a:r>
           </a:p>
         </p:txBody>
@@ -5863,7 +5863,7 @@
                 </a:solidFill>
                 <a:latin typeface="Helvetica Neue"/>
               </a:rPr>
-              <a:t>723</a:t>
+              <a:t>733</a:t>
             </a:r>
           </a:p>
         </p:txBody>
@@ -6159,7 +6159,7 @@
             <a:avLst/>
           </a:prstGeom>
           <a:solidFill>
-            <a:srgbClr val="1B7A43"/>
+            <a:srgbClr val="6B7082"/>
           </a:solidFill>
           <a:ln>
             <a:noFill/>
@@ -6213,11 +6213,11 @@
             <a:r>
               <a:rPr sz="900" b="1">
                 <a:solidFill>
-                  <a:srgbClr val="1B7A43"/>
-                </a:solidFill>
-                <a:latin typeface="Helvetica Neue"/>
-              </a:rPr>
-              <a:t>FIFA — POSITIVE</a:t>
+                  <a:srgbClr val="6B7082"/>
+                </a:solidFill>
+                <a:latin typeface="Helvetica Neue"/>
+              </a:rPr>
+              <a:t>MILITARY_SERVICE</a:t>
             </a:r>
           </a:p>
         </p:txBody>
@@ -6251,7 +6251,7 @@
                 </a:solidFill>
                 <a:latin typeface="Georgia"/>
               </a:rPr>
-              <a:t>4,605</a:t>
+              <a:t>3,241</a:t>
             </a:r>
           </a:p>
         </p:txBody>
@@ -6319,7 +6319,7 @@
                 </a:solidFill>
                 <a:latin typeface="Helvetica Neue"/>
               </a:rPr>
-              <a:t>10 posts · 46,049 total views</a:t>
+              <a:t>19 posts · 61,577 total views</a:t>
             </a:r>
           </a:p>
         </p:txBody>
@@ -6383,7 +6383,7 @@
             <a:avLst/>
           </a:prstGeom>
           <a:solidFill>
-            <a:srgbClr val="990011"/>
+            <a:srgbClr val="1B7A43"/>
           </a:solidFill>
           <a:ln>
             <a:noFill/>
@@ -6437,11 +6437,11 @@
             <a:r>
               <a:rPr sz="900" b="1">
                 <a:solidFill>
-                  <a:srgbClr val="990011"/>
-                </a:solidFill>
-                <a:latin typeface="Helvetica Neue"/>
-              </a:rPr>
-              <a:t>AMERICAN PRIDE</a:t>
+                  <a:srgbClr val="1B7A43"/>
+                </a:solidFill>
+                <a:latin typeface="Helvetica Neue"/>
+              </a:rPr>
+              <a:t>FIFA — POSITIVE</a:t>
             </a:r>
           </a:p>
         </p:txBody>
@@ -6475,7 +6475,7 @@
                 </a:solidFill>
                 <a:latin typeface="Georgia"/>
               </a:rPr>
-              <a:t>7,171</a:t>
+              <a:t>4,605</a:t>
             </a:r>
           </a:p>
         </p:txBody>
@@ -6543,7 +6543,7 @@
                 </a:solidFill>
                 <a:latin typeface="Helvetica Neue"/>
               </a:rPr>
-              <a:t>5 posts · 35,856 total views</a:t>
+              <a:t>10 posts · 46,049 total views</a:t>
             </a:r>
           </a:p>
         </p:txBody>
@@ -6607,7 +6607,7 @@
             <a:avLst/>
           </a:prstGeom>
           <a:solidFill>
-            <a:srgbClr val="6B7082"/>
+            <a:srgbClr val="1B7A43"/>
           </a:solidFill>
           <a:ln>
             <a:noFill/>
@@ -6661,11 +6661,11 @@
             <a:r>
               <a:rPr sz="900" b="1">
                 <a:solidFill>
-                  <a:srgbClr val="6B7082"/>
-                </a:solidFill>
-                <a:latin typeface="Helvetica Neue"/>
-              </a:rPr>
-              <a:t>OTHER</a:t>
+                  <a:srgbClr val="1B7A43"/>
+                </a:solidFill>
+                <a:latin typeface="Helvetica Neue"/>
+              </a:rPr>
+              <a:t>FOOD</a:t>
             </a:r>
           </a:p>
         </p:txBody>
@@ -6699,7 +6699,7 @@
                 </a:solidFill>
                 <a:latin typeface="Georgia"/>
               </a:rPr>
-              <a:t>476</a:t>
+              <a:t>1,572</a:t>
             </a:r>
           </a:p>
         </p:txBody>
@@ -6767,7 +6767,7 @@
                 </a:solidFill>
                 <a:latin typeface="Helvetica Neue"/>
               </a:rPr>
-              <a:t>54 posts · 25,722 total views</a:t>
+              <a:t>25 posts · 39,293 total views</a:t>
             </a:r>
           </a:p>
         </p:txBody>
@@ -6831,7 +6831,7 @@
             <a:avLst/>
           </a:prstGeom>
           <a:solidFill>
-            <a:srgbClr val="141833"/>
+            <a:srgbClr val="6B7082"/>
           </a:solidFill>
           <a:ln>
             <a:noFill/>
@@ -6885,11 +6885,11 @@
             <a:r>
               <a:rPr sz="900" b="1">
                 <a:solidFill>
-                  <a:srgbClr val="141833"/>
-                </a:solidFill>
-                <a:latin typeface="Helvetica Neue"/>
-              </a:rPr>
-              <a:t>COMMUNITY LOCAL</a:t>
+                  <a:srgbClr val="6B7082"/>
+                </a:solidFill>
+                <a:latin typeface="Helvetica Neue"/>
+              </a:rPr>
+              <a:t>OTHER</a:t>
             </a:r>
           </a:p>
         </p:txBody>
@@ -6923,7 +6923,7 @@
                 </a:solidFill>
                 <a:latin typeface="Georgia"/>
               </a:rPr>
-              <a:t>755</a:t>
+              <a:t>510</a:t>
             </a:r>
           </a:p>
         </p:txBody>
@@ -6991,7 +6991,7 @@
                 </a:solidFill>
                 <a:latin typeface="Helvetica Neue"/>
               </a:rPr>
-              <a:t>15 posts · 11,331 total views</a:t>
+              <a:t>31 posts · 15,825 total views</a:t>
             </a:r>
           </a:p>
         </p:txBody>
@@ -7055,7 +7055,7 @@
             <a:avLst/>
           </a:prstGeom>
           <a:solidFill>
-            <a:srgbClr val="2F3C7E"/>
+            <a:srgbClr val="141833"/>
           </a:solidFill>
           <a:ln>
             <a:noFill/>
@@ -7109,11 +7109,11 @@
             <a:r>
               <a:rPr sz="900" b="1">
                 <a:solidFill>
-                  <a:srgbClr val="2F3C7E"/>
-                </a:solidFill>
-                <a:latin typeface="Helvetica Neue"/>
-              </a:rPr>
-              <a:t>JUDICIAL</a:t>
+                  <a:srgbClr val="141833"/>
+                </a:solidFill>
+                <a:latin typeface="Helvetica Neue"/>
+              </a:rPr>
+              <a:t>COMMUNITY LOCAL</a:t>
             </a:r>
           </a:p>
         </p:txBody>
@@ -7147,7 +7147,7 @@
                 </a:solidFill>
                 <a:latin typeface="Georgia"/>
               </a:rPr>
-              <a:t>297</a:t>
+              <a:t>869</a:t>
             </a:r>
           </a:p>
         </p:txBody>
@@ -7215,7 +7215,7 @@
                 </a:solidFill>
                 <a:latin typeface="Helvetica Neue"/>
               </a:rPr>
-              <a:t>17 posts · 5,042 total views</a:t>
+              <a:t>11 posts · 9,564 total views</a:t>
             </a:r>
           </a:p>
         </p:txBody>
@@ -7337,7 +7337,7 @@
                 </a:solidFill>
                 <a:latin typeface="Helvetica Neue"/>
               </a:rPr>
-              <a:t>ELECTIONS</a:t>
+              <a:t>JUDICIAL</a:t>
             </a:r>
           </a:p>
         </p:txBody>
@@ -7371,7 +7371,7 @@
                 </a:solidFill>
                 <a:latin typeface="Georgia"/>
               </a:rPr>
-              <a:t>1,012</a:t>
+              <a:t>303</a:t>
             </a:r>
           </a:p>
         </p:txBody>
@@ -7439,7 +7439,7 @@
                 </a:solidFill>
                 <a:latin typeface="Helvetica Neue"/>
               </a:rPr>
-              <a:t>4 posts · 4,050 total views</a:t>
+              <a:t>23 posts · 6,978 total views</a:t>
             </a:r>
           </a:p>
         </p:txBody>
@@ -7503,7 +7503,7 @@
             <a:avLst/>
           </a:prstGeom>
           <a:solidFill>
-            <a:srgbClr val="C9A227"/>
+            <a:srgbClr val="990011"/>
           </a:solidFill>
           <a:ln>
             <a:noFill/>
@@ -7557,11 +7557,11 @@
             <a:r>
               <a:rPr sz="900" b="1">
                 <a:solidFill>
-                  <a:srgbClr val="C9A227"/>
-                </a:solidFill>
-                <a:latin typeface="Helvetica Neue"/>
-              </a:rPr>
-              <a:t>DOWNTOWN DEVELOPMENT</a:t>
+                  <a:srgbClr val="990011"/>
+                </a:solidFill>
+                <a:latin typeface="Helvetica Neue"/>
+              </a:rPr>
+              <a:t>AMERICAN PRIDE</a:t>
             </a:r>
           </a:p>
         </p:txBody>
@@ -7595,7 +7595,7 @@
                 </a:solidFill>
                 <a:latin typeface="Georgia"/>
               </a:rPr>
-              <a:t>1,006</a:t>
+              <a:t>480</a:t>
             </a:r>
           </a:p>
         </p:txBody>
@@ -7663,7 +7663,7 @@
                 </a:solidFill>
                 <a:latin typeface="Helvetica Neue"/>
               </a:rPr>
-              <a:t>4 posts · 4,026 total views</a:t>
+              <a:t>12 posts · 5,764 total views</a:t>
             </a:r>
           </a:p>
         </p:txBody>
@@ -7819,7 +7819,7 @@
                 </a:solidFill>
                 <a:latin typeface="Georgia"/>
               </a:rPr>
-              <a:t>468</a:t>
+              <a:t>449</a:t>
             </a:r>
           </a:p>
         </p:txBody>
@@ -7887,7 +7887,7 @@
                 </a:solidFill>
                 <a:latin typeface="Helvetica Neue"/>
               </a:rPr>
-              <a:t>8 posts · 3,744 total views</a:t>
+              <a:t>11 posts · 4,941 total views</a:t>
             </a:r>
           </a:p>
         </p:txBody>
@@ -8513,7 +8513,7 @@
                 </a:solidFill>
                 <a:latin typeface="Helvetica Neue"/>
               </a:rPr>
-              <a:t>33,400</a:t>
+              <a:t>37,400</a:t>
             </a:r>
           </a:p>
         </p:txBody>
@@ -8547,7 +8547,7 @@
                 </a:solidFill>
                 <a:latin typeface="Helvetica Neue"/>
               </a:rPr>
-              <a:t>2,122</a:t>
+              <a:t>2,413</a:t>
             </a:r>
           </a:p>
         </p:txBody>
@@ -8581,7 +8581,7 @@
                 </a:solidFill>
                 <a:latin typeface="Helvetica Neue"/>
               </a:rPr>
-              <a:t>American Pride</a:t>
+              <a:t>Military Service</a:t>
             </a:r>
           </a:p>
         </p:txBody>
@@ -9053,7 +9053,7 @@
                 </a:solidFill>
                 <a:latin typeface="Helvetica Neue"/>
               </a:rPr>
-              <a:t>7,698</a:t>
+              <a:t>8,253</a:t>
             </a:r>
           </a:p>
         </p:txBody>
@@ -9087,7 +9087,7 @@
                 </a:solidFill>
                 <a:latin typeface="Helvetica Neue"/>
               </a:rPr>
-              <a:t>377</a:t>
+              <a:t>396</a:t>
             </a:r>
           </a:p>
         </p:txBody>
@@ -9121,7 +9121,7 @@
                 </a:solidFill>
                 <a:latin typeface="Helvetica Neue"/>
               </a:rPr>
-              <a:t>Other</a:t>
+              <a:t>Food</a:t>
             </a:r>
           </a:p>
         </p:txBody>
@@ -9719,7 +9719,7 @@
                 </a:solidFill>
                 <a:latin typeface="Helvetica Neue"/>
               </a:rPr>
-              <a:t>20 years later, this letter still resonates. It sparked the Downtown Improv</a:t>
+              <a:t>Not everyone deployed sees combat, even with 20 years in. Your MOS matters.</a:t>
             </a:r>
           </a:p>
         </p:txBody>
@@ -9753,7 +9753,7 @@
                 </a:solidFill>
                 <a:latin typeface="Helvetica Neue"/>
               </a:rPr>
-              <a:t>2,390</a:t>
+              <a:t>5,132</a:t>
             </a:r>
           </a:p>
         </p:txBody>
@@ -9787,7 +9787,7 @@
                 </a:solidFill>
                 <a:latin typeface="Helvetica Neue"/>
               </a:rPr>
-              <a:t>39</a:t>
+              <a:t>186</a:t>
             </a:r>
           </a:p>
         </p:txBody>
@@ -9821,7 +9821,7 @@
                 </a:solidFill>
                 <a:latin typeface="Helvetica Neue"/>
               </a:rPr>
-              <a:t>Downtown Development</a:t>
+              <a:t>Military Service</a:t>
             </a:r>
           </a:p>
         </p:txBody>
@@ -9889,7 +9889,7 @@
                 </a:solidFill>
                 <a:latin typeface="Helvetica Neue"/>
               </a:rPr>
-              <a:t>FB</a:t>
+              <a:t>IG</a:t>
             </a:r>
           </a:p>
         </p:txBody>
@@ -9923,7 +9923,7 @@
                 </a:solidFill>
                 <a:latin typeface="Helvetica Neue"/>
               </a:rPr>
-              <a:t>Discover Pop's Wings, a family-owned gem in Downey serving up more than jus</a:t>
+              <a:t>Found an amazing pastrami sandwich at Pop's Wings! Toasted bread, tender pa</a:t>
             </a:r>
           </a:p>
         </p:txBody>
@@ -9957,7 +9957,7 @@
                 </a:solidFill>
                 <a:latin typeface="Helvetica Neue"/>
               </a:rPr>
-              <a:t>1,788</a:t>
+              <a:t>4,748</a:t>
             </a:r>
           </a:p>
         </p:txBody>
@@ -9991,7 +9991,7 @@
                 </a:solidFill>
                 <a:latin typeface="Helvetica Neue"/>
               </a:rPr>
-              <a:t>28</a:t>
+              <a:t>128</a:t>
             </a:r>
           </a:p>
         </p:txBody>
@@ -10025,7 +10025,7 @@
                 </a:solidFill>
                 <a:latin typeface="Helvetica Neue"/>
               </a:rPr>
-              <a:t>Community Local</a:t>
+              <a:t>Food</a:t>
             </a:r>
           </a:p>
         </p:txBody>
@@ -10137,7 +10137,7 @@
                 </a:solidFill>
                 <a:latin typeface="Helvetica Neue"/>
               </a:rPr>
-              <a:t>FB</a:t>
+              <a:t>IG</a:t>
             </a:r>
           </a:p>
         </p:txBody>
@@ -10171,7 +10171,7 @@
                 </a:solidFill>
                 <a:latin typeface="Helvetica Neue"/>
               </a:rPr>
-              <a:t>Downey City Council adopted a new Code of Ethics and Conduct for commission</a:t>
+              <a:t>Dreamed of college, but the cost was a barrier. Joined the Army, and they p</a:t>
             </a:r>
           </a:p>
         </p:txBody>
@@ -10205,7 +10205,7 @@
                 </a:solidFill>
                 <a:latin typeface="Helvetica Neue"/>
               </a:rPr>
-              <a:t>1,705</a:t>
+              <a:t>4,043</a:t>
             </a:r>
           </a:p>
         </p:txBody>
@@ -10239,7 +10239,7 @@
                 </a:solidFill>
                 <a:latin typeface="Helvetica Neue"/>
               </a:rPr>
-              <a:t>19</a:t>
+              <a:t>143</a:t>
             </a:r>
           </a:p>
         </p:txBody>
@@ -10273,7 +10273,7 @@
                 </a:solidFill>
                 <a:latin typeface="Helvetica Neue"/>
               </a:rPr>
-              <a:t>Community Local</a:t>
+              <a:t>Military Service</a:t>
             </a:r>
           </a:p>
         </p:txBody>
@@ -10549,7 +10549,7 @@
                 </a:solidFill>
                 <a:latin typeface="Helvetica Neue"/>
               </a:rPr>
-              <a:t>—  June posts (Jun 8–30 window): 131  →  July posts (Jul 1–31 window): 133</a:t>
+              <a:t>—  June posts (Jun 8–30): 131  →  July posts (Jul 1–31): 163</a:t>
             </a:r>
           </a:p>
         </p:txBody>
@@ -10583,7 +10583,7 @@
                 </a:solidFill>
                 <a:latin typeface="Helvetica Neue"/>
               </a:rPr>
-              <a:t>—  Political-only spine broadened to include Downey growth stories + American pride content</a:t>
+              <a:t>—  #1 post in July: [TT] 37,400 views — Military Service — "Combat jobs aren't for everyone. See how your MOS determines depl"</a:t>
             </a:r>
           </a:p>
         </p:txBody>
@@ -10617,7 +10617,7 @@
                 </a:solidFill>
                 <a:latin typeface="Helvetica Neue"/>
               </a:rPr>
-              <a:t>—  Paul Granata episode (Jul 2) opened a new lane: local business + downtown revival</a:t>
+              <a:t>—  Top-earning category: Military Service (61,577 total views in July)</a:t>
             </a:r>
           </a:p>
         </p:txBody>
@@ -10651,7 +10651,7 @@
                 </a:solidFill>
                 <a:latin typeface="Helvetica Neue"/>
               </a:rPr>
-              <a:t>—  July 4th content proved the audience responds to positive/celebratory as well</a:t>
+              <a:t>—  Content split: 0 investigative posts vs 98 positive/community posts</a:t>
             </a:r>
           </a:p>
         </p:txBody>
@@ -10685,7 +10685,7 @@
                 </a:solidFill>
                 <a:latin typeface="Helvetica Neue"/>
               </a:rPr>
-              <a:t>—  Brand growth self-reporting posts landed — audience validated the meta-narrative</a:t>
+              <a:t>—  Dominant platform for reach: Tiktok (largest share of total July views)</a:t>
             </a:r>
           </a:p>
         </p:txBody>

</xml_diff>

<commit_message>
Scheduled snapshot t18 (2026-08-12): fresh IG/FB/YT/TT + rebuilt decks
Co-Authored-By: Claude Opus 4.7 (1M context) <noreply@anthropic.com>
</commit_message>
<xml_diff>
--- a/MONTHLY_REPORT_2026-07.pptx
+++ b/MONTHLY_REPORT_2026-07.pptx
@@ -4063,7 +4063,7 @@
                 </a:solidFill>
                 <a:latin typeface="Georgia"/>
               </a:rPr>
-              <a:t>1,121 → 335</a:t>
+              <a:t>1,121 → 336</a:t>
             </a:r>
           </a:p>
         </p:txBody>
@@ -4709,7 +4709,7 @@
                 </a:solidFill>
                 <a:latin typeface="Georgia"/>
               </a:rPr>
-              <a:t>47,752</a:t>
+              <a:t>47,823</a:t>
             </a:r>
           </a:p>
         </p:txBody>
@@ -5045,7 +5045,7 @@
                 </a:solidFill>
                 <a:latin typeface="Georgia"/>
               </a:rPr>
-              <a:t>111,267</a:t>
+              <a:t>112,130</a:t>
             </a:r>
           </a:p>
         </p:txBody>
@@ -5381,7 +5381,7 @@
                 </a:solidFill>
                 <a:latin typeface="Georgia"/>
               </a:rPr>
-              <a:t>45,774</a:t>
+              <a:t>45,849</a:t>
             </a:r>
           </a:p>
         </p:txBody>
@@ -5717,7 +5717,7 @@
                 </a:solidFill>
                 <a:latin typeface="Georgia"/>
               </a:rPr>
-              <a:t>359</a:t>
+              <a:t>363</a:t>
             </a:r>
           </a:p>
         </p:txBody>
@@ -5863,7 +5863,7 @@
                 </a:solidFill>
                 <a:latin typeface="Helvetica Neue"/>
               </a:rPr>
-              <a:t>733</a:t>
+              <a:t>734</a:t>
             </a:r>
           </a:p>
         </p:txBody>
@@ -6251,7 +6251,7 @@
                 </a:solidFill>
                 <a:latin typeface="Georgia"/>
               </a:rPr>
-              <a:t>3,241</a:t>
+              <a:t>3,272</a:t>
             </a:r>
           </a:p>
         </p:txBody>
@@ -6319,7 +6319,7 @@
                 </a:solidFill>
                 <a:latin typeface="Helvetica Neue"/>
               </a:rPr>
-              <a:t>19 posts · 61,577 total views</a:t>
+              <a:t>19 posts · 62,175 total views</a:t>
             </a:r>
           </a:p>
         </p:txBody>
@@ -6699,7 +6699,7 @@
                 </a:solidFill>
                 <a:latin typeface="Georgia"/>
               </a:rPr>
-              <a:t>1,572</a:t>
+              <a:t>1,583</a:t>
             </a:r>
           </a:p>
         </p:txBody>
@@ -6767,7 +6767,7 @@
                 </a:solidFill>
                 <a:latin typeface="Helvetica Neue"/>
               </a:rPr>
-              <a:t>25 posts · 39,293 total views</a:t>
+              <a:t>25 posts · 39,565 total views</a:t>
             </a:r>
           </a:p>
         </p:txBody>
@@ -6923,7 +6923,7 @@
                 </a:solidFill>
                 <a:latin typeface="Georgia"/>
               </a:rPr>
-              <a:t>510</a:t>
+              <a:t>513</a:t>
             </a:r>
           </a:p>
         </p:txBody>
@@ -6991,7 +6991,7 @@
                 </a:solidFill>
                 <a:latin typeface="Helvetica Neue"/>
               </a:rPr>
-              <a:t>31 posts · 15,825 total views</a:t>
+              <a:t>31 posts · 15,902 total views</a:t>
             </a:r>
           </a:p>
         </p:txBody>
@@ -8513,7 +8513,7 @@
                 </a:solidFill>
                 <a:latin typeface="Helvetica Neue"/>
               </a:rPr>
-              <a:t>37,400</a:t>
+              <a:t>37,900</a:t>
             </a:r>
           </a:p>
         </p:txBody>
@@ -8547,7 +8547,7 @@
                 </a:solidFill>
                 <a:latin typeface="Helvetica Neue"/>
               </a:rPr>
-              <a:t>2,413</a:t>
+              <a:t>2,472</a:t>
             </a:r>
           </a:p>
         </p:txBody>
@@ -9053,7 +9053,7 @@
                 </a:solidFill>
                 <a:latin typeface="Helvetica Neue"/>
               </a:rPr>
-              <a:t>8,253</a:t>
+              <a:t>8,352</a:t>
             </a:r>
           </a:p>
         </p:txBody>
@@ -9087,7 +9087,7 @@
                 </a:solidFill>
                 <a:latin typeface="Helvetica Neue"/>
               </a:rPr>
-              <a:t>396</a:t>
+              <a:t>405</a:t>
             </a:r>
           </a:p>
         </p:txBody>
@@ -9753,7 +9753,7 @@
                 </a:solidFill>
                 <a:latin typeface="Helvetica Neue"/>
               </a:rPr>
-              <a:t>5,132</a:t>
+              <a:t>5,139</a:t>
             </a:r>
           </a:p>
         </p:txBody>
@@ -9957,7 +9957,7 @@
                 </a:solidFill>
                 <a:latin typeface="Helvetica Neue"/>
               </a:rPr>
-              <a:t>4,748</a:t>
+              <a:t>4,752</a:t>
             </a:r>
           </a:p>
         </p:txBody>
@@ -10583,7 +10583,7 @@
                 </a:solidFill>
                 <a:latin typeface="Helvetica Neue"/>
               </a:rPr>
-              <a:t>—  #1 post in July: [TT] 37,400 views — Military Service — "Combat jobs aren't for everyone. See how your MOS determines depl"</a:t>
+              <a:t>—  #1 post in July: [TT] 37,900 views — Military Service — "Combat jobs aren't for everyone. See how your MOS determines depl"</a:t>
             </a:r>
           </a:p>
         </p:txBody>
@@ -10617,7 +10617,7 @@
                 </a:solidFill>
                 <a:latin typeface="Helvetica Neue"/>
               </a:rPr>
-              <a:t>—  Top-earning category: Military Service (61,577 total views in July)</a:t>
+              <a:t>—  Top-earning category: Military Service (62,175 total views in July)</a:t>
             </a:r>
           </a:p>
         </p:txBody>

</xml_diff>

<commit_message>
Scheduled snapshot t19 (2026-08-14): fresh IG/FB/YT/TT + rebuilt decks
Co-Authored-By: Claude Opus 4.7 (1M context) <noreply@anthropic.com>
</commit_message>
<xml_diff>
--- a/MONTHLY_REPORT_2026-07.pptx
+++ b/MONTHLY_REPORT_2026-07.pptx
@@ -4709,7 +4709,7 @@
                 </a:solidFill>
                 <a:latin typeface="Georgia"/>
               </a:rPr>
-              <a:t>47,823</a:t>
+              <a:t>47,889</a:t>
             </a:r>
           </a:p>
         </p:txBody>
@@ -5381,7 +5381,7 @@
                 </a:solidFill>
                 <a:latin typeface="Georgia"/>
               </a:rPr>
-              <a:t>45,849</a:t>
+              <a:t>45,883</a:t>
             </a:r>
           </a:p>
         </p:txBody>
@@ -5717,7 +5717,7 @@
                 </a:solidFill>
                 <a:latin typeface="Georgia"/>
               </a:rPr>
-              <a:t>363</a:t>
+              <a:t>366</a:t>
             </a:r>
           </a:p>
         </p:txBody>
@@ -5863,7 +5863,7 @@
                 </a:solidFill>
                 <a:latin typeface="Helvetica Neue"/>
               </a:rPr>
-              <a:t>734</a:t>
+              <a:t>736</a:t>
             </a:r>
           </a:p>
         </p:txBody>
@@ -6251,7 +6251,7 @@
                 </a:solidFill>
                 <a:latin typeface="Georgia"/>
               </a:rPr>
-              <a:t>3,272</a:t>
+              <a:t>3,273</a:t>
             </a:r>
           </a:p>
         </p:txBody>
@@ -6319,7 +6319,7 @@
                 </a:solidFill>
                 <a:latin typeface="Helvetica Neue"/>
               </a:rPr>
-              <a:t>19 posts · 62,175 total views</a:t>
+              <a:t>19 posts · 62,185 total views</a:t>
             </a:r>
           </a:p>
         </p:txBody>
@@ -6699,7 +6699,7 @@
                 </a:solidFill>
                 <a:latin typeface="Georgia"/>
               </a:rPr>
-              <a:t>1,583</a:t>
+              <a:t>1,584</a:t>
             </a:r>
           </a:p>
         </p:txBody>
@@ -6767,7 +6767,7 @@
                 </a:solidFill>
                 <a:latin typeface="Helvetica Neue"/>
               </a:rPr>
-              <a:t>25 posts · 39,565 total views</a:t>
+              <a:t>25 posts · 39,592 total views</a:t>
             </a:r>
           </a:p>
         </p:txBody>
@@ -6923,7 +6923,7 @@
                 </a:solidFill>
                 <a:latin typeface="Georgia"/>
               </a:rPr>
-              <a:t>513</a:t>
+              <a:t>515</a:t>
             </a:r>
           </a:p>
         </p:txBody>
@@ -6991,7 +6991,7 @@
                 </a:solidFill>
                 <a:latin typeface="Helvetica Neue"/>
               </a:rPr>
-              <a:t>31 posts · 15,902 total views</a:t>
+              <a:t>31 posts · 15,968 total views</a:t>
             </a:r>
           </a:p>
         </p:txBody>
@@ -10617,7 +10617,7 @@
                 </a:solidFill>
                 <a:latin typeface="Helvetica Neue"/>
               </a:rPr>
-              <a:t>—  Top-earning category: Military Service (62,175 total views in July)</a:t>
+              <a:t>—  Top-earning category: Military Service (62,185 total views in July)</a:t>
             </a:r>
           </a:p>
         </p:txBody>

</xml_diff>

<commit_message>
Scheduled snapshot t20 (2026-08-17): fresh IG/FB/YT/TT + rebuilt decks
Co-Authored-By: Claude Opus 4.7 (1M context) <noreply@anthropic.com>
</commit_message>
<xml_diff>
--- a/MONTHLY_REPORT_2026-07.pptx
+++ b/MONTHLY_REPORT_2026-07.pptx
@@ -4709,7 +4709,7 @@
                 </a:solidFill>
                 <a:latin typeface="Georgia"/>
               </a:rPr>
-              <a:t>47,889</a:t>
+              <a:t>47,910</a:t>
             </a:r>
           </a:p>
         </p:txBody>
@@ -5045,7 +5045,7 @@
                 </a:solidFill>
                 <a:latin typeface="Georgia"/>
               </a:rPr>
-              <a:t>112,130</a:t>
+              <a:t>112,774</a:t>
             </a:r>
           </a:p>
         </p:txBody>
@@ -5381,7 +5381,7 @@
                 </a:solidFill>
                 <a:latin typeface="Georgia"/>
               </a:rPr>
-              <a:t>45,883</a:t>
+              <a:t>45,896</a:t>
             </a:r>
           </a:p>
         </p:txBody>
@@ -5717,7 +5717,7 @@
                 </a:solidFill>
                 <a:latin typeface="Georgia"/>
               </a:rPr>
-              <a:t>366</a:t>
+              <a:t>367</a:t>
             </a:r>
           </a:p>
         </p:txBody>
@@ -6251,7 +6251,7 @@
                 </a:solidFill>
                 <a:latin typeface="Georgia"/>
               </a:rPr>
-              <a:t>3,273</a:t>
+              <a:t>3,283</a:t>
             </a:r>
           </a:p>
         </p:txBody>
@@ -6319,7 +6319,7 @@
                 </a:solidFill>
                 <a:latin typeface="Helvetica Neue"/>
               </a:rPr>
-              <a:t>19 posts · 62,185 total views</a:t>
+              <a:t>19 posts · 62,380 total views</a:t>
             </a:r>
           </a:p>
         </p:txBody>
@@ -6699,7 +6699,7 @@
                 </a:solidFill>
                 <a:latin typeface="Georgia"/>
               </a:rPr>
-              <a:t>1,584</a:t>
+              <a:t>1,597</a:t>
             </a:r>
           </a:p>
         </p:txBody>
@@ -6767,7 +6767,7 @@
                 </a:solidFill>
                 <a:latin typeface="Helvetica Neue"/>
               </a:rPr>
-              <a:t>25 posts · 39,592 total views</a:t>
+              <a:t>25 posts · 39,915 total views</a:t>
             </a:r>
           </a:p>
         </p:txBody>
@@ -6923,7 +6923,7 @@
                 </a:solidFill>
                 <a:latin typeface="Georgia"/>
               </a:rPr>
-              <a:t>515</a:t>
+              <a:t>518</a:t>
             </a:r>
           </a:p>
         </p:txBody>
@@ -6991,7 +6991,7 @@
                 </a:solidFill>
                 <a:latin typeface="Helvetica Neue"/>
               </a:rPr>
-              <a:t>31 posts · 15,968 total views</a:t>
+              <a:t>31 posts · 16,058 total views</a:t>
             </a:r>
           </a:p>
         </p:txBody>
@@ -10137,7 +10137,7 @@
                 </a:solidFill>
                 <a:latin typeface="Helvetica Neue"/>
               </a:rPr>
-              <a:t>IG</a:t>
+              <a:t>TT</a:t>
             </a:r>
           </a:p>
         </p:txBody>
@@ -10171,7 +10171,7 @@
                 </a:solidFill>
                 <a:latin typeface="Helvetica Neue"/>
               </a:rPr>
-              <a:t>Dreamed of college, but the cost was a barrier. Joined the Army, and they p</a:t>
+              <a:t>Downtown Downey sushi spot alert! Starfish Sushi's bento box lunch is a mus</a:t>
             </a:r>
           </a:p>
         </p:txBody>
@@ -10205,7 +10205,7 @@
                 </a:solidFill>
                 <a:latin typeface="Helvetica Neue"/>
               </a:rPr>
-              <a:t>4,043</a:t>
+              <a:t>4,105</a:t>
             </a:r>
           </a:p>
         </p:txBody>
@@ -10239,7 +10239,7 @@
                 </a:solidFill>
                 <a:latin typeface="Helvetica Neue"/>
               </a:rPr>
-              <a:t>143</a:t>
+              <a:t>168</a:t>
             </a:r>
           </a:p>
         </p:txBody>
@@ -10273,7 +10273,7 @@
                 </a:solidFill>
                 <a:latin typeface="Helvetica Neue"/>
               </a:rPr>
-              <a:t>Military Service</a:t>
+              <a:t>Food</a:t>
             </a:r>
           </a:p>
         </p:txBody>
@@ -10617,7 +10617,7 @@
                 </a:solidFill>
                 <a:latin typeface="Helvetica Neue"/>
               </a:rPr>
-              <a:t>—  Top-earning category: Military Service (62,185 total views in July)</a:t>
+              <a:t>—  Top-earning category: Military Service (62,380 total views in July)</a:t>
             </a:r>
           </a:p>
         </p:txBody>

</xml_diff>

<commit_message>
Scheduled snapshot t21 (2026-08-19): fresh IG/FB/YT/TT + rebuilt decks
Co-Authored-By: Claude Opus 4.7 (1M context) <noreply@anthropic.com>
</commit_message>
<xml_diff>
--- a/MONTHLY_REPORT_2026-07.pptx
+++ b/MONTHLY_REPORT_2026-07.pptx
@@ -4709,7 +4709,7 @@
                 </a:solidFill>
                 <a:latin typeface="Georgia"/>
               </a:rPr>
-              <a:t>47,910</a:t>
+              <a:t>48,331</a:t>
             </a:r>
           </a:p>
         </p:txBody>
@@ -5045,7 +5045,7 @@
                 </a:solidFill>
                 <a:latin typeface="Georgia"/>
               </a:rPr>
-              <a:t>112,774</a:t>
+              <a:t>113,075</a:t>
             </a:r>
           </a:p>
         </p:txBody>
@@ -5381,7 +5381,7 @@
                 </a:solidFill>
                 <a:latin typeface="Georgia"/>
               </a:rPr>
-              <a:t>45,896</a:t>
+              <a:t>45,898</a:t>
             </a:r>
           </a:p>
         </p:txBody>
@@ -5863,7 +5863,7 @@
                 </a:solidFill>
                 <a:latin typeface="Helvetica Neue"/>
               </a:rPr>
-              <a:t>736</a:t>
+              <a:t>737</a:t>
             </a:r>
           </a:p>
         </p:txBody>
@@ -6251,7 +6251,7 @@
                 </a:solidFill>
                 <a:latin typeface="Georgia"/>
               </a:rPr>
-              <a:t>3,283</a:t>
+              <a:t>3,291</a:t>
             </a:r>
           </a:p>
         </p:txBody>
@@ -6319,7 +6319,7 @@
                 </a:solidFill>
                 <a:latin typeface="Helvetica Neue"/>
               </a:rPr>
-              <a:t>19 posts · 62,380 total views</a:t>
+              <a:t>19 posts · 62,524 total views</a:t>
             </a:r>
           </a:p>
         </p:txBody>
@@ -6699,7 +6699,7 @@
                 </a:solidFill>
                 <a:latin typeface="Georgia"/>
               </a:rPr>
-              <a:t>1,597</a:t>
+              <a:t>1,616</a:t>
             </a:r>
           </a:p>
         </p:txBody>
@@ -6767,7 +6767,7 @@
                 </a:solidFill>
                 <a:latin typeface="Helvetica Neue"/>
               </a:rPr>
-              <a:t>25 posts · 39,915 total views</a:t>
+              <a:t>25 posts · 40,399 total views</a:t>
             </a:r>
           </a:p>
         </p:txBody>
@@ -6923,7 +6923,7 @@
                 </a:solidFill>
                 <a:latin typeface="Georgia"/>
               </a:rPr>
-              <a:t>518</a:t>
+              <a:t>520</a:t>
             </a:r>
           </a:p>
         </p:txBody>
@@ -6991,7 +6991,7 @@
                 </a:solidFill>
                 <a:latin typeface="Helvetica Neue"/>
               </a:rPr>
-              <a:t>31 posts · 16,058 total views</a:t>
+              <a:t>31 posts · 16,121 total views</a:t>
             </a:r>
           </a:p>
         </p:txBody>
@@ -10205,7 +10205,7 @@
                 </a:solidFill>
                 <a:latin typeface="Helvetica Neue"/>
               </a:rPr>
-              <a:t>4,105</a:t>
+              <a:t>4,148</a:t>
             </a:r>
           </a:p>
         </p:txBody>
@@ -10239,7 +10239,7 @@
                 </a:solidFill>
                 <a:latin typeface="Helvetica Neue"/>
               </a:rPr>
-              <a:t>168</a:t>
+              <a:t>169</a:t>
             </a:r>
           </a:p>
         </p:txBody>
@@ -10617,7 +10617,7 @@
                 </a:solidFill>
                 <a:latin typeface="Helvetica Neue"/>
               </a:rPr>
-              <a:t>—  Top-earning category: Military Service (62,380 total views in July)</a:t>
+              <a:t>—  Top-earning category: Military Service (62,524 total views in July)</a:t>
             </a:r>
           </a:p>
         </p:txBody>

</xml_diff>

<commit_message>
Scheduled snapshot t22 (2026-08-21): fresh IG/FB/YT/TT + rebuilt decks
Co-Authored-By: Claude Opus 4.7 (1M context) <noreply@anthropic.com>
</commit_message>
<xml_diff>
--- a/MONTHLY_REPORT_2026-07.pptx
+++ b/MONTHLY_REPORT_2026-07.pptx
@@ -4709,7 +4709,7 @@
                 </a:solidFill>
                 <a:latin typeface="Georgia"/>
               </a:rPr>
-              <a:t>48,331</a:t>
+              <a:t>48,359</a:t>
             </a:r>
           </a:p>
         </p:txBody>
@@ -5045,7 +5045,7 @@
                 </a:solidFill>
                 <a:latin typeface="Georgia"/>
               </a:rPr>
-              <a:t>113,075</a:t>
+              <a:t>113,109</a:t>
             </a:r>
           </a:p>
         </p:txBody>
@@ -5717,7 +5717,7 @@
                 </a:solidFill>
                 <a:latin typeface="Georgia"/>
               </a:rPr>
-              <a:t>367</a:t>
+              <a:t>368</a:t>
             </a:r>
           </a:p>
         </p:txBody>
@@ -6319,7 +6319,7 @@
                 </a:solidFill>
                 <a:latin typeface="Helvetica Neue"/>
               </a:rPr>
-              <a:t>19 posts · 62,524 total views</a:t>
+              <a:t>19 posts · 62,525 total views</a:t>
             </a:r>
           </a:p>
         </p:txBody>
@@ -6699,7 +6699,7 @@
                 </a:solidFill>
                 <a:latin typeface="Georgia"/>
               </a:rPr>
-              <a:t>1,616</a:t>
+              <a:t>1,618</a:t>
             </a:r>
           </a:p>
         </p:txBody>
@@ -6767,7 +6767,7 @@
                 </a:solidFill>
                 <a:latin typeface="Helvetica Neue"/>
               </a:rPr>
-              <a:t>25 posts · 40,399 total views</a:t>
+              <a:t>25 posts · 40,444 total views</a:t>
             </a:r>
           </a:p>
         </p:txBody>
@@ -6923,7 +6923,7 @@
                 </a:solidFill>
                 <a:latin typeface="Georgia"/>
               </a:rPr>
-              <a:t>520</a:t>
+              <a:t>521</a:t>
             </a:r>
           </a:p>
         </p:txBody>
@@ -6991,7 +6991,7 @@
                 </a:solidFill>
                 <a:latin typeface="Helvetica Neue"/>
               </a:rPr>
-              <a:t>31 posts · 16,121 total views</a:t>
+              <a:t>31 posts · 16,138 total views</a:t>
             </a:r>
           </a:p>
         </p:txBody>
@@ -10617,7 +10617,7 @@
                 </a:solidFill>
                 <a:latin typeface="Helvetica Neue"/>
               </a:rPr>
-              <a:t>—  Top-earning category: Military Service (62,524 total views in July)</a:t>
+              <a:t>—  Top-earning category: Military Service (62,525 total views in July)</a:t>
             </a:r>
           </a:p>
         </p:txBody>

</xml_diff>

<commit_message>
Scheduled snapshot t23 (2026-08-24): fresh IG/FB/YT/TT + rebuilt decks
Co-Authored-By: Claude Opus 4.7 (1M context) <noreply@anthropic.com>
</commit_message>
<xml_diff>
--- a/MONTHLY_REPORT_2026-07.pptx
+++ b/MONTHLY_REPORT_2026-07.pptx
@@ -5045,7 +5045,7 @@
                 </a:solidFill>
                 <a:latin typeface="Georgia"/>
               </a:rPr>
-              <a:t>113,109</a:t>
+              <a:t>113,125</a:t>
             </a:r>
           </a:p>
         </p:txBody>
@@ -5717,7 +5717,7 @@
                 </a:solidFill>
                 <a:latin typeface="Georgia"/>
               </a:rPr>
-              <a:t>368</a:t>
+              <a:t>370</a:t>
             </a:r>
           </a:p>
         </p:txBody>
@@ -6319,7 +6319,7 @@
                 </a:solidFill>
                 <a:latin typeface="Helvetica Neue"/>
               </a:rPr>
-              <a:t>19 posts · 62,525 total views</a:t>
+              <a:t>19 posts · 62,526 total views</a:t>
             </a:r>
           </a:p>
         </p:txBody>
@@ -6991,7 +6991,7 @@
                 </a:solidFill>
                 <a:latin typeface="Helvetica Neue"/>
               </a:rPr>
-              <a:t>31 posts · 16,138 total views</a:t>
+              <a:t>31 posts · 16,154 total views</a:t>
             </a:r>
           </a:p>
         </p:txBody>
@@ -10617,7 +10617,7 @@
                 </a:solidFill>
                 <a:latin typeface="Helvetica Neue"/>
               </a:rPr>
-              <a:t>—  Top-earning category: Military Service (62,525 total views in July)</a:t>
+              <a:t>—  Top-earning category: Military Service (62,526 total views in July)</a:t>
             </a:r>
           </a:p>
         </p:txBody>

</xml_diff>

<commit_message>
Scheduled snapshot t24 (2026-08-26): fresh IG/FB/YT/TT + rebuilt decks
Co-Authored-By: Claude Opus 4.7 (1M context) <noreply@anthropic.com>
</commit_message>
<xml_diff>
--- a/MONTHLY_REPORT_2026-07.pptx
+++ b/MONTHLY_REPORT_2026-07.pptx
@@ -5717,7 +5717,7 @@
                 </a:solidFill>
                 <a:latin typeface="Georgia"/>
               </a:rPr>
-              <a:t>370</a:t>
+              <a:t>372</a:t>
             </a:r>
           </a:p>
         </p:txBody>
@@ -5863,7 +5863,7 @@
                 </a:solidFill>
                 <a:latin typeface="Helvetica Neue"/>
               </a:rPr>
-              <a:t>737</a:t>
+              <a:t>738</a:t>
             </a:r>
           </a:p>
         </p:txBody>
@@ -6319,7 +6319,7 @@
                 </a:solidFill>
                 <a:latin typeface="Helvetica Neue"/>
               </a:rPr>
-              <a:t>19 posts · 62,526 total views</a:t>
+              <a:t>19 posts · 62,527 total views</a:t>
             </a:r>
           </a:p>
         </p:txBody>
@@ -10617,7 +10617,7 @@
                 </a:solidFill>
                 <a:latin typeface="Helvetica Neue"/>
               </a:rPr>
-              <a:t>—  Top-earning category: Military Service (62,526 total views in July)</a:t>
+              <a:t>—  Top-earning category: Military Service (62,527 total views in July)</a:t>
             </a:r>
           </a:p>
         </p:txBody>

</xml_diff>

<commit_message>
Rebuild July/Aug monthly decks with new taxonomy; replace stale 57%-other narrative with data-driven text
</commit_message>
<xml_diff>
--- a/MONTHLY_REPORT_2026-07.pptx
+++ b/MONTHLY_REPORT_2026-07.pptx
@@ -3839,7 +3839,7 @@
                 </a:solidFill>
                 <a:latin typeface="Georgia"/>
               </a:rPr>
-              <a:t>2,500 → 0</a:t>
+              <a:t>2,429 → 0</a:t>
             </a:r>
           </a:p>
         </p:txBody>
@@ -4063,7 +4063,7 @@
                 </a:solidFill>
                 <a:latin typeface="Georgia"/>
               </a:rPr>
-              <a:t>1,121 → 336</a:t>
+              <a:t>1,009 → 551</a:t>
             </a:r>
           </a:p>
         </p:txBody>
@@ -4097,7 +4097,7 @@
                 </a:solidFill>
                 <a:latin typeface="Helvetica Neue"/>
               </a:rPr>
-              <a:t>▼ -70%</a:t>
+              <a:t>▼ -45%</a:t>
             </a:r>
           </a:p>
         </p:txBody>
@@ -5717,7 +5717,7 @@
                 </a:solidFill>
                 <a:latin typeface="Georgia"/>
               </a:rPr>
-              <a:t>372</a:t>
+              <a:t>476</a:t>
             </a:r>
           </a:p>
         </p:txBody>
@@ -5863,7 +5863,7 @@
                 </a:solidFill>
                 <a:latin typeface="Helvetica Neue"/>
               </a:rPr>
-              <a:t>738</a:t>
+              <a:t>834</a:t>
             </a:r>
           </a:p>
         </p:txBody>
@@ -6159,7 +6159,7 @@
             <a:avLst/>
           </a:prstGeom>
           <a:solidFill>
-            <a:srgbClr val="6B7082"/>
+            <a:srgbClr val="C9A227"/>
           </a:solidFill>
           <a:ln>
             <a:noFill/>
@@ -6213,11 +6213,11 @@
             <a:r>
               <a:rPr sz="900" b="1">
                 <a:solidFill>
-                  <a:srgbClr val="6B7082"/>
-                </a:solidFill>
-                <a:latin typeface="Helvetica Neue"/>
-              </a:rPr>
-              <a:t>MILITARY_SERVICE</a:t>
+                  <a:srgbClr val="C9A227"/>
+                </a:solidFill>
+                <a:latin typeface="Helvetica Neue"/>
+              </a:rPr>
+              <a:t>MILITARY SERVICE</a:t>
             </a:r>
           </a:p>
         </p:txBody>
@@ -6251,7 +6251,7 @@
                 </a:solidFill>
                 <a:latin typeface="Georgia"/>
               </a:rPr>
-              <a:t>3,291</a:t>
+              <a:t>2,566</a:t>
             </a:r>
           </a:p>
         </p:txBody>
@@ -6319,7 +6319,7 @@
                 </a:solidFill>
                 <a:latin typeface="Helvetica Neue"/>
               </a:rPr>
-              <a:t>19 posts · 62,527 total views</a:t>
+              <a:t>27 posts · 69,292 total views</a:t>
             </a:r>
           </a:p>
         </p:txBody>
@@ -6831,7 +6831,7 @@
             <a:avLst/>
           </a:prstGeom>
           <a:solidFill>
-            <a:srgbClr val="6B7082"/>
+            <a:srgbClr val="141833"/>
           </a:solidFill>
           <a:ln>
             <a:noFill/>
@@ -6885,11 +6885,11 @@
             <a:r>
               <a:rPr sz="900" b="1">
                 <a:solidFill>
-                  <a:srgbClr val="6B7082"/>
-                </a:solidFill>
-                <a:latin typeface="Helvetica Neue"/>
-              </a:rPr>
-              <a:t>OTHER</a:t>
+                  <a:srgbClr val="141833"/>
+                </a:solidFill>
+                <a:latin typeface="Helvetica Neue"/>
+              </a:rPr>
+              <a:t>COMMUNITY LOCAL</a:t>
             </a:r>
           </a:p>
         </p:txBody>
@@ -6923,7 +6923,7 @@
                 </a:solidFill>
                 <a:latin typeface="Georgia"/>
               </a:rPr>
-              <a:t>521</a:t>
+              <a:t>869</a:t>
             </a:r>
           </a:p>
         </p:txBody>
@@ -6991,7 +6991,7 @@
                 </a:solidFill>
                 <a:latin typeface="Helvetica Neue"/>
               </a:rPr>
-              <a:t>31 posts · 16,154 total views</a:t>
+              <a:t>11 posts · 9,564 total views</a:t>
             </a:r>
           </a:p>
         </p:txBody>
@@ -7055,7 +7055,7 @@
             <a:avLst/>
           </a:prstGeom>
           <a:solidFill>
-            <a:srgbClr val="141833"/>
+            <a:srgbClr val="2F3C7E"/>
           </a:solidFill>
           <a:ln>
             <a:noFill/>
@@ -7109,11 +7109,11 @@
             <a:r>
               <a:rPr sz="900" b="1">
                 <a:solidFill>
-                  <a:srgbClr val="141833"/>
-                </a:solidFill>
-                <a:latin typeface="Helvetica Neue"/>
-              </a:rPr>
-              <a:t>COMMUNITY LOCAL</a:t>
+                  <a:srgbClr val="2F3C7E"/>
+                </a:solidFill>
+                <a:latin typeface="Helvetica Neue"/>
+              </a:rPr>
+              <a:t>JUDICIAL</a:t>
             </a:r>
           </a:p>
         </p:txBody>
@@ -7147,7 +7147,7 @@
                 </a:solidFill>
                 <a:latin typeface="Georgia"/>
               </a:rPr>
-              <a:t>869</a:t>
+              <a:t>292</a:t>
             </a:r>
           </a:p>
         </p:txBody>
@@ -7215,7 +7215,7 @@
                 </a:solidFill>
                 <a:latin typeface="Helvetica Neue"/>
               </a:rPr>
-              <a:t>11 posts · 9,564 total views</a:t>
+              <a:t>27 posts · 7,875 total views</a:t>
             </a:r>
           </a:p>
         </p:txBody>
@@ -7279,7 +7279,7 @@
             <a:avLst/>
           </a:prstGeom>
           <a:solidFill>
-            <a:srgbClr val="2F3C7E"/>
+            <a:srgbClr val="990011"/>
           </a:solidFill>
           <a:ln>
             <a:noFill/>
@@ -7333,11 +7333,11 @@
             <a:r>
               <a:rPr sz="900" b="1">
                 <a:solidFill>
-                  <a:srgbClr val="2F3C7E"/>
-                </a:solidFill>
-                <a:latin typeface="Helvetica Neue"/>
-              </a:rPr>
-              <a:t>JUDICIAL</a:t>
+                  <a:srgbClr val="990011"/>
+                </a:solidFill>
+                <a:latin typeface="Helvetica Neue"/>
+              </a:rPr>
+              <a:t>AMERICAN PRIDE</a:t>
             </a:r>
           </a:p>
         </p:txBody>
@@ -7371,7 +7371,7 @@
                 </a:solidFill>
                 <a:latin typeface="Georgia"/>
               </a:rPr>
-              <a:t>303</a:t>
+              <a:t>480</a:t>
             </a:r>
           </a:p>
         </p:txBody>
@@ -7439,7 +7439,7 @@
                 </a:solidFill>
                 <a:latin typeface="Helvetica Neue"/>
               </a:rPr>
-              <a:t>23 posts · 6,978 total views</a:t>
+              <a:t>12 posts · 5,764 total views</a:t>
             </a:r>
           </a:p>
         </p:txBody>
@@ -7503,7 +7503,7 @@
             <a:avLst/>
           </a:prstGeom>
           <a:solidFill>
-            <a:srgbClr val="990011"/>
+            <a:srgbClr val="141833"/>
           </a:solidFill>
           <a:ln>
             <a:noFill/>
@@ -7557,11 +7557,11 @@
             <a:r>
               <a:rPr sz="900" b="1">
                 <a:solidFill>
-                  <a:srgbClr val="990011"/>
-                </a:solidFill>
-                <a:latin typeface="Helvetica Neue"/>
-              </a:rPr>
-              <a:t>AMERICAN PRIDE</a:t>
+                  <a:srgbClr val="141833"/>
+                </a:solidFill>
+                <a:latin typeface="Helvetica Neue"/>
+              </a:rPr>
+              <a:t>COMMUNITY EVENTS</a:t>
             </a:r>
           </a:p>
         </p:txBody>
@@ -7595,7 +7595,7 @@
                 </a:solidFill>
                 <a:latin typeface="Georgia"/>
               </a:rPr>
-              <a:t>480</a:t>
+              <a:t>449</a:t>
             </a:r>
           </a:p>
         </p:txBody>
@@ -7663,7 +7663,7 @@
                 </a:solidFill>
                 <a:latin typeface="Helvetica Neue"/>
               </a:rPr>
-              <a:t>12 posts · 5,764 total views</a:t>
+              <a:t>11 posts · 4,941 total views</a:t>
             </a:r>
           </a:p>
         </p:txBody>
@@ -7727,7 +7727,7 @@
             <a:avLst/>
           </a:prstGeom>
           <a:solidFill>
-            <a:srgbClr val="141833"/>
+            <a:srgbClr val="C9A227"/>
           </a:solidFill>
           <a:ln>
             <a:noFill/>
@@ -7781,11 +7781,11 @@
             <a:r>
               <a:rPr sz="900" b="1">
                 <a:solidFill>
-                  <a:srgbClr val="141833"/>
-                </a:solidFill>
-                <a:latin typeface="Helvetica Neue"/>
-              </a:rPr>
-              <a:t>COMMUNITY EVENTS</a:t>
+                  <a:srgbClr val="C9A227"/>
+                </a:solidFill>
+                <a:latin typeface="Helvetica Neue"/>
+              </a:rPr>
+              <a:t>DOWNTOWN DEVELOPMENT</a:t>
             </a:r>
           </a:p>
         </p:txBody>
@@ -7819,7 +7819,7 @@
                 </a:solidFill>
                 <a:latin typeface="Georgia"/>
               </a:rPr>
-              <a:t>449</a:t>
+              <a:t>1,006</a:t>
             </a:r>
           </a:p>
         </p:txBody>
@@ -7887,7 +7887,7 @@
                 </a:solidFill>
                 <a:latin typeface="Helvetica Neue"/>
               </a:rPr>
-              <a:t>11 posts · 4,941 total views</a:t>
+              <a:t>4 posts · 4,026 total views</a:t>
             </a:r>
           </a:p>
         </p:txBody>
@@ -10617,7 +10617,7 @@
                 </a:solidFill>
                 <a:latin typeface="Helvetica Neue"/>
               </a:rPr>
-              <a:t>—  Top-earning category: Military Service (62,527 total views in July)</a:t>
+              <a:t>—  Top-earning category: Military Service (69,292 total views in July)</a:t>
             </a:r>
           </a:p>
         </p:txBody>
@@ -10651,7 +10651,7 @@
                 </a:solidFill>
                 <a:latin typeface="Helvetica Neue"/>
               </a:rPr>
-              <a:t>—  Content split: 0 investigative posts vs 98 positive/community posts</a:t>
+              <a:t>—  Content split: 0 investigative posts vs 111 positive/community posts</a:t>
             </a:r>
           </a:p>
         </p:txBody>

</xml_diff>